<commit_message>
Presentation and report: author and links to repository and site
</commit_message>
<xml_diff>
--- a/deck/out/agrokast_presentation.pptx
+++ b/deck/out/agrokast_presentation.pptx
@@ -2609,7 +2609,7 @@
           <a:lstStyle/>
           <a:p>
             <a:r>
-              <a:t>Здравствуйте! Меня зовут Фамилия И.О., это проект «Агрокаст» — решение задачи 5 кейса «Своё Фермерство». Мы прогнозируем урожайность на пять дат сезона, с 1 мая до конца, и на этой основе подсказываем, как немного изменить посевы, чтобы заработать больше. За шесть минут я покажу не просто обученную модель, а полноценное исследование: данные, честную проверку, результаты и работающий сайт.</a:t>
+              <a:t>Здравствуйте! Меня зовут Соболев Даниил, это проект «Агрокаст» — решение задачи 5 кейса «Своё Фермерство». Мы прогнозируем урожайность на пять дат сезона, с 1 мая до конца, и на этой основе подсказываем, как немного изменить посевы, чтобы заработать больше. За шесть минут я покажу не просто обученную модель, а полноценное исследование: данные, честную проверку, результаты и работающий сайт.</a:t>
             </a:r>
           </a:p>
         </p:txBody>
@@ -6724,7 +6724,7 @@
                 </a:solidFill>
                 <a:latin typeface="Calibri"/>
               </a:rPr>
-              <a:t>Фамилия И.О.</a:t>
+              <a:t>Соболев Даниил</a:t>
             </a:r>
             <a:r>
               <a:rPr sz="1500" b="0" i="0" lang="ru-RU">
@@ -8197,13 +8197,13 @@
               <a:t>Код и сайт: </a:t>
             </a:r>
             <a:r>
-              <a:rPr sz="1500" b="1" i="0" lang="ru-RU">
-                <a:solidFill>
-                  <a:srgbClr val="A6611A"/>
-                </a:solidFill>
-                <a:latin typeface="Calibri"/>
-              </a:rPr>
-              <a:t>[заполнить: ссылка на репозиторий]</a:t>
+              <a:rPr sz="1500" b="0" i="0" lang="ru-RU">
+                <a:solidFill>
+                  <a:srgbClr val="1E2420"/>
+                </a:solidFill>
+                <a:latin typeface="Calibri"/>
+              </a:rPr>
+              <a:t>https://parampaika.github.io/AgroCast/</a:t>
             </a:r>
           </a:p>
         </p:txBody>
@@ -10003,7 +10003,7 @@
                 </a:solidFill>
                 <a:latin typeface="Calibri"/>
               </a:rPr>
-              <a:t>Фамилия И.О.</a:t>
+              <a:t>Соболев Даниил</a:t>
             </a:r>
           </a:p>
           <a:p>
@@ -10115,7 +10115,7 @@
                 </a:solidFill>
                 <a:latin typeface="Calibri"/>
               </a:rPr>
-              <a:t>[заполнить]</a:t>
+              <a:t>https://github.com/Parampaika/AgroCast</a:t>
             </a:r>
           </a:p>
         </p:txBody>

</xml_diff>

<commit_message>
Presentation: product is the plot calculator, honest caveats on multipliers and the actual-weather estimate
</commit_message>
<xml_diff>
--- a/deck/out/agrokast_presentation.pptx
+++ b/deck/out/agrokast_presentation.pptx
@@ -2609,7 +2609,7 @@
           <a:lstStyle/>
           <a:p>
             <a:r>
-              <a:t>Здравствуйте! Меня зовут Соболев Даниил, это проект «Агрокаст» — решение задачи 5 кейса «Своё Фермерство». Мы прогнозируем урожайность на пять дат сезона, с 1 мая до конца, и на этой основе подсказываем, как немного изменить посевы, чтобы заработать больше. За шесть минут я покажу не просто обученную модель, а полноценное исследование: данные, честную проверку, результаты и работающий сайт.</a:t>
+              <a:t>Здравствуйте! Меня зовут Соболев Даниил, это проект «Агрокаст» — решение задачи 5 кейса «Своё Фермерство». Это калькулятор урожайности участка: вы вводите регион, площадь, почву, сорт и агротехнику и получаете тонны с гектара, общий сбор, выручку и маржу по нескольким культурам. Под капотом — региональная модель прогноза на пять дат сезона, с 1 мая до конца, и оптимизация посевов. За шесть минут я покажу данные, честную проверку, результаты и работающий сайт.</a:t>
             </a:r>
           </a:p>
         </p:txBody>
@@ -2679,7 +2679,7 @@
           <a:lstStyle/>
           <a:p>
             <a:r>
-              <a:t>Всё это собрано в сайте «Агрокаст»: карта по регионам и культурам со шкалой дат, карточка региона с факторами прогноза, калькулятор хозяйства с поправками на почву, сорт и агротехнику и экран оптимизации с ползунком «менять не больше X процентов». Сайт статический, работает без сервера, а код, данные и отчёт лежат в репозитории.</a:t>
+              <a:t>Главный экран сайта — калькулятор участка: вводите регион, площадь по культурам, почву, сорт и агротехнику и сразу видите тонны с гектара, общий сбор, выручку, маржу и сценарии «плохой, обычный, хороший год». Затем карта регионов — это и есть региональная модель, основа калькулятора, — и экран оптимизации с ползунком «менять не больше X процентов». Модель считает прогноз региона; почва, сорт, агротехника и затраты — допущения. Сайт статический, а код и отчёт лежат в репозитории.</a:t>
             </a:r>
           </a:p>
         </p:txBody>
@@ -2749,7 +2749,7 @@
           <a:lstStyle/>
           <a:p>
             <a:r>
-              <a:t>Ограничения называю прямо: уровень прогноза — регион, ряды короткие, интервалы широкие, а затраты в оптимизации — допущения. Дальше — районы и хозяйства, спутник в реальном времени, совместные сценарии цены и урожая, удобрения и агротехника и интеграция с данными банка.</a:t>
+              <a:t>Ограничения называю прямо: модель региональная, а не полевая, множители почвы, сорта и агротехники — допущения, ряды короткие, интервалы широкие, затраты — допущения. Дальше — калибровка множителей по опытным станциям, данным хозяйств и банка, спутник в реальном времени, сценарии цены и урожая и интеграция с данными банка.</a:t>
             </a:r>
           </a:p>
         </p:txBody>
@@ -2889,7 +2889,7 @@
           <a:lstStyle/>
           <a:p>
             <a:r>
-              <a:t>Кейс просит калькулятор урожайности в тоннах на гектар и в общем объёме и объяснение пользы для планирования затрат и доходов. Фермеру прогноз нужен, чтобы решать, что сеять и сколько вложить, банку — чтобы видеть риск кредитов до уборки. Мы пошли дальше: прогноз превращается в рекомендацию, что именно поменять в плане посевов.</a:t>
+              <a:t>Кейс просит оценить урожайность по площади, почве, климату, сорту и агротехнике, показать т/га и общий объём для нескольких культур и объяснить пользу для планирования затрат и доходов. Фермеру это нужно, чтобы решать, что сеять и сколько вложить, банку — чтобы видеть риск кредитов до уборки. Мы пошли дальше: расчёт превращается в рекомендацию, что именно поменять в плане посевов. Мы не обещаем точный прогноз для поля — только честную оценку с интервалом.</a:t>
             </a:r>
           </a:p>
         </p:txBody>
@@ -3099,7 +3099,7 @@
           <a:lstStyle/>
           <a:p>
             <a:r>
-              <a:t>Модель устроена просто: урожайность — это тренд, умноженный на поправку за погоду, спутник и почву. Прогноз строится на пять дат, и всё, что наступит позже даты прогноза, замаскировано. Проверка скользящая, по времени: для каждого года с 2012 по 2025 модель обучается только на прошлом. Случайного разбиения нет, потому что год — общий шок для всех регионов.</a:t>
+              <a:t>Региональная модель устроена просто: урожайность — это тренд, умноженный на поправку за погоду, спутник и почву региона. Прогноз строится на пять дат, и всё, что наступит позже даты прогноза, замаскировано. Проверка скользящая, по времени: для каждого года с 2012 по 2025 модель обучается только на прошлом. Случайного разбиения нет, потому что год — общий шок для всех регионов. Оговорка: базовый прогноз региона обучен на данных, а влияние почвы, сорта и агротехники участка — множители-допущения. Открытых данных о сортах и агротехнике по хозяйствам нет. «Конец сезона» — это оценка по фактической погоде, а не прогноз.</a:t>
             </a:r>
           </a:p>
         </p:txBody>
@@ -6469,8 +6469,8 @@
         </p:nvSpPr>
         <p:spPr>
           <a:xfrm>
-            <a:off x="548640" y="2331720"/>
-            <a:ext cx="6309360" cy="1280160"/>
+            <a:off x="548640" y="2286000"/>
+            <a:ext cx="6309360" cy="1188720"/>
           </a:xfrm>
           <a:prstGeom prst="rect">
             <a:avLst/>
@@ -6487,13 +6487,13 @@
               </a:lnSpc>
             </a:pPr>
             <a:r>
-              <a:rPr sz="3000" b="0" i="0" lang="ru-RU">
+              <a:rPr sz="2600" b="0" i="0" lang="ru-RU">
                 <a:solidFill>
                   <a:srgbClr val="FFFFFF"/>
                 </a:solidFill>
                 <a:latin typeface="Calibri"/>
               </a:rPr>
-              <a:t>Прогноз урожайности на 5 дат сезона + оптимизация структуры посевов</a:t>
+              <a:t>Калькулятор урожайности участка: регион, площадь, почва, сорт, агротехника → т/га, сбор, выручка, маржа</a:t>
             </a:r>
           </a:p>
         </p:txBody>
@@ -6506,8 +6506,8 @@
         </p:nvSpPr>
         <p:spPr>
           <a:xfrm>
-            <a:off x="548640" y="3977639"/>
-            <a:ext cx="2103120" cy="594360"/>
+            <a:off x="548640" y="3611880"/>
+            <a:ext cx="6400800" cy="457200"/>
           </a:xfrm>
           <a:prstGeom prst="rect">
             <a:avLst/>
@@ -6515,18 +6515,18 @@
           <a:noFill/>
         </p:spPr>
         <p:txBody>
-          <a:bodyPr wrap="square" lIns="0" rIns="0" tIns="0" bIns="0" anchor="ctr"/>
+          <a:bodyPr wrap="square" lIns="0" rIns="0" tIns="0" bIns="0" anchor="t"/>
           <a:lstStyle/>
           <a:p>
             <a:pPr algn="l"/>
             <a:r>
-              <a:rPr sz="3400" b="1" i="0" lang="ru-RU">
-                <a:solidFill>
-                  <a:srgbClr val="E2B04A"/>
-                </a:solidFill>
-                <a:latin typeface="Calibri"/>
-              </a:rPr>
-              <a:t>−30 %</a:t>
+              <a:rPr sz="1400" b="0" i="0" lang="ru-RU">
+                <a:solidFill>
+                  <a:srgbClr val="D5E3DA"/>
+                </a:solidFill>
+                <a:latin typeface="Calibri"/>
+              </a:rPr>
+              <a:t>Под капотом — региональная модель на 5 дат сезона и оптимизация посевов</a:t>
             </a:r>
           </a:p>
         </p:txBody>
@@ -6539,8 +6539,8 @@
         </p:nvSpPr>
         <p:spPr>
           <a:xfrm>
-            <a:off x="548640" y="4572000"/>
-            <a:ext cx="1965960" cy="685800"/>
+            <a:off x="548640" y="4160520"/>
+            <a:ext cx="2103120" cy="594360"/>
           </a:xfrm>
           <a:prstGeom prst="rect">
             <a:avLst/>
@@ -6548,18 +6548,18 @@
           <a:noFill/>
         </p:spPr>
         <p:txBody>
-          <a:bodyPr wrap="square" lIns="0" rIns="0" tIns="0" bIns="0" anchor="t"/>
+          <a:bodyPr wrap="square" lIns="0" rIns="0" tIns="0" bIns="0" anchor="ctr"/>
           <a:lstStyle/>
           <a:p>
             <a:pPr algn="l"/>
             <a:r>
-              <a:rPr sz="1300" b="0" i="0" lang="ru-RU">
-                <a:solidFill>
-                  <a:srgbClr val="D5E3DA"/>
-                </a:solidFill>
-                <a:latin typeface="Calibri"/>
-              </a:rPr>
-              <a:t>ошибки к прогнозу «как в прошлом году»</a:t>
+              <a:rPr sz="3400" b="1" i="0" lang="ru-RU">
+                <a:solidFill>
+                  <a:srgbClr val="E2B04A"/>
+                </a:solidFill>
+                <a:latin typeface="Calibri"/>
+              </a:rPr>
+              <a:t>−30 %</a:t>
             </a:r>
           </a:p>
         </p:txBody>
@@ -6572,8 +6572,8 @@
         </p:nvSpPr>
         <p:spPr>
           <a:xfrm>
-            <a:off x="2743200" y="3977639"/>
-            <a:ext cx="2103120" cy="594360"/>
+            <a:off x="548640" y="4754880"/>
+            <a:ext cx="1965960" cy="685800"/>
           </a:xfrm>
           <a:prstGeom prst="rect">
             <a:avLst/>
@@ -6581,18 +6581,18 @@
           <a:noFill/>
         </p:spPr>
         <p:txBody>
-          <a:bodyPr wrap="square" lIns="0" rIns="0" tIns="0" bIns="0" anchor="ctr"/>
+          <a:bodyPr wrap="square" lIns="0" rIns="0" tIns="0" bIns="0" anchor="t"/>
           <a:lstStyle/>
           <a:p>
             <a:pPr algn="l"/>
             <a:r>
-              <a:rPr sz="3400" b="1" i="0" lang="ru-RU">
-                <a:solidFill>
-                  <a:srgbClr val="E2B04A"/>
-                </a:solidFill>
-                <a:latin typeface="Calibri"/>
-              </a:rPr>
-              <a:t>4 069</a:t>
+              <a:rPr sz="1300" b="0" i="0" lang="ru-RU">
+                <a:solidFill>
+                  <a:srgbClr val="D5E3DA"/>
+                </a:solidFill>
+                <a:latin typeface="Calibri"/>
+              </a:rPr>
+              <a:t>ошибки к прогнозу «как в прошлом году»</a:t>
             </a:r>
           </a:p>
         </p:txBody>
@@ -6605,8 +6605,8 @@
         </p:nvSpPr>
         <p:spPr>
           <a:xfrm>
-            <a:off x="2743200" y="4572000"/>
-            <a:ext cx="1965960" cy="685800"/>
+            <a:off x="2743200" y="4160520"/>
+            <a:ext cx="2103120" cy="594360"/>
           </a:xfrm>
           <a:prstGeom prst="rect">
             <a:avLst/>
@@ -6614,18 +6614,18 @@
           <a:noFill/>
         </p:spPr>
         <p:txBody>
-          <a:bodyPr wrap="square" lIns="0" rIns="0" tIns="0" bIns="0" anchor="t"/>
+          <a:bodyPr wrap="square" lIns="0" rIns="0" tIns="0" bIns="0" anchor="ctr"/>
           <a:lstStyle/>
           <a:p>
             <a:pPr algn="l"/>
             <a:r>
-              <a:rPr sz="1300" b="0" i="0" lang="ru-RU">
-                <a:solidFill>
-                  <a:srgbClr val="D5E3DA"/>
-                </a:solidFill>
-                <a:latin typeface="Calibri"/>
-              </a:rPr>
-              <a:t>конфигураций моделей на единой проверке</a:t>
+              <a:rPr sz="3400" b="1" i="0" lang="ru-RU">
+                <a:solidFill>
+                  <a:srgbClr val="E2B04A"/>
+                </a:solidFill>
+                <a:latin typeface="Calibri"/>
+              </a:rPr>
+              <a:t>4 069</a:t>
             </a:r>
           </a:p>
         </p:txBody>
@@ -6638,8 +6638,8 @@
         </p:nvSpPr>
         <p:spPr>
           <a:xfrm>
-            <a:off x="4937760" y="3977639"/>
-            <a:ext cx="2103120" cy="594360"/>
+            <a:off x="2743200" y="4754880"/>
+            <a:ext cx="1965960" cy="685800"/>
           </a:xfrm>
           <a:prstGeom prst="rect">
             <a:avLst/>
@@ -6647,18 +6647,18 @@
           <a:noFill/>
         </p:spPr>
         <p:txBody>
-          <a:bodyPr wrap="square" lIns="0" rIns="0" tIns="0" bIns="0" anchor="ctr"/>
+          <a:bodyPr wrap="square" lIns="0" rIns="0" tIns="0" bIns="0" anchor="t"/>
           <a:lstStyle/>
           <a:p>
             <a:pPr algn="l"/>
             <a:r>
-              <a:rPr sz="3400" b="1" i="0" lang="ru-RU">
-                <a:solidFill>
-                  <a:srgbClr val="E2B04A"/>
-                </a:solidFill>
-                <a:latin typeface="Calibri"/>
-              </a:rPr>
-              <a:t>+1 301 ₽/га</a:t>
+              <a:rPr sz="1300" b="0" i="0" lang="ru-RU">
+                <a:solidFill>
+                  <a:srgbClr val="D5E3DA"/>
+                </a:solidFill>
+                <a:latin typeface="Calibri"/>
+              </a:rPr>
+              <a:t>конфигураций моделей на единой проверке</a:t>
             </a:r>
           </a:p>
         </p:txBody>
@@ -6671,8 +6671,8 @@
         </p:nvSpPr>
         <p:spPr>
           <a:xfrm>
-            <a:off x="4937760" y="4572000"/>
-            <a:ext cx="1965960" cy="685800"/>
+            <a:off x="4937760" y="4160520"/>
+            <a:ext cx="2103120" cy="594360"/>
           </a:xfrm>
           <a:prstGeom prst="rect">
             <a:avLst/>
@@ -6680,6 +6680,39 @@
           <a:noFill/>
         </p:spPr>
         <p:txBody>
+          <a:bodyPr wrap="square" lIns="0" rIns="0" tIns="0" bIns="0" anchor="ctr"/>
+          <a:lstStyle/>
+          <a:p>
+            <a:pPr algn="l"/>
+            <a:r>
+              <a:rPr sz="3400" b="1" i="0" lang="ru-RU">
+                <a:solidFill>
+                  <a:srgbClr val="E2B04A"/>
+                </a:solidFill>
+                <a:latin typeface="Calibri"/>
+              </a:rPr>
+              <a:t>+1 301 ₽/га</a:t>
+            </a:r>
+          </a:p>
+        </p:txBody>
+      </p:sp>
+      <p:sp>
+        <p:nvSpPr>
+          <p:cNvPr id="11" name="TextBox 10"/>
+          <p:cNvSpPr txBox="1"/>
+          <p:nvPr/>
+        </p:nvSpPr>
+        <p:spPr>
+          <a:xfrm>
+            <a:off x="4937760" y="4754880"/>
+            <a:ext cx="1965960" cy="685800"/>
+          </a:xfrm>
+          <a:prstGeom prst="rect">
+            <a:avLst/>
+          </a:prstGeom>
+          <a:noFill/>
+        </p:spPr>
+        <p:txBody>
           <a:bodyPr wrap="square" lIns="0" rIns="0" tIns="0" bIns="0" anchor="t"/>
           <a:lstStyle/>
           <a:p>
@@ -6698,7 +6731,7 @@
       </p:sp>
       <p:sp>
         <p:nvSpPr>
-          <p:cNvPr id="11" name="Автор"/>
+          <p:cNvPr id="12" name="Автор"/>
           <p:cNvSpPr txBox="1"/>
           <p:nvPr/>
         </p:nvSpPr>
@@ -6740,7 +6773,7 @@
       </p:sp>
       <p:sp>
         <p:nvSpPr>
-          <p:cNvPr id="12" name="TextBox 11"/>
+          <p:cNvPr id="13" name="TextBox 12"/>
           <p:cNvSpPr txBox="1"/>
           <p:nvPr/>
         </p:nvSpPr>
@@ -6773,7 +6806,7 @@
       </p:sp>
       <p:sp>
         <p:nvSpPr>
-          <p:cNvPr id="13" name="Rounded Rectangle 12"/>
+          <p:cNvPr id="14" name="Rounded Rectangle 13"/>
           <p:cNvSpPr/>
           <p:nvPr/>
         </p:nvSpPr>
@@ -6817,7 +6850,7 @@
       </p:sp>
       <p:sp>
         <p:nvSpPr>
-          <p:cNvPr id="14" name="TextBox 13"/>
+          <p:cNvPr id="15" name="TextBox 14"/>
           <p:cNvSpPr txBox="1"/>
           <p:nvPr/>
         </p:nvSpPr>
@@ -6850,7 +6883,7 @@
       </p:sp>
       <p:sp>
         <p:nvSpPr>
-          <p:cNvPr id="15" name="Freeform 14"/>
+          <p:cNvPr id="16" name="Freeform 15"/>
           <p:cNvSpPr/>
           <p:nvPr/>
         </p:nvSpPr>
@@ -6935,7 +6968,7 @@
       </p:sp>
       <p:sp>
         <p:nvSpPr>
-          <p:cNvPr id="16" name="Freeform 15"/>
+          <p:cNvPr id="17" name="Freeform 16"/>
           <p:cNvSpPr/>
           <p:nvPr/>
         </p:nvSpPr>
@@ -7020,49 +7053,13 @@
       </p:sp>
       <p:cxnSp>
         <p:nvCxnSpPr>
-          <p:cNvPr id="17" name="Connector 16"/>
-          <p:cNvCxnSpPr/>
-          <p:nvPr/>
-        </p:nvCxnSpPr>
-        <p:spPr>
-          <a:xfrm>
-            <a:off x="7909560" y="1737360"/>
-            <a:ext cx="0" cy="3337560"/>
-          </a:xfrm>
-          <a:prstGeom prst="line">
-            <a:avLst/>
-          </a:prstGeom>
-          <a:ln w="9525">
-            <a:solidFill>
-              <a:srgbClr val="3E6E58"/>
-            </a:solidFill>
-            <a:prstDash val="dash"/>
-          </a:ln>
-        </p:spPr>
-        <p:style>
-          <a:lnRef idx="2">
-            <a:schemeClr val="accent1"/>
-          </a:lnRef>
-          <a:fillRef idx="0">
-            <a:schemeClr val="accent1"/>
-          </a:fillRef>
-          <a:effectRef idx="1">
-            <a:schemeClr val="accent1"/>
-          </a:effectRef>
-          <a:fontRef idx="minor">
-            <a:schemeClr val="tx1"/>
-          </a:fontRef>
-        </p:style>
-      </p:cxnSp>
-      <p:cxnSp>
-        <p:nvCxnSpPr>
           <p:cNvPr id="18" name="Connector 17"/>
           <p:cNvCxnSpPr/>
           <p:nvPr/>
         </p:nvCxnSpPr>
         <p:spPr>
           <a:xfrm>
-            <a:off x="8693658" y="1737360"/>
+            <a:off x="7909560" y="1737360"/>
             <a:ext cx="0" cy="3337560"/>
           </a:xfrm>
           <a:prstGeom prst="line">
@@ -7098,7 +7095,7 @@
         </p:nvCxnSpPr>
         <p:spPr>
           <a:xfrm>
-            <a:off x="9477756" y="1737360"/>
+            <a:off x="8693658" y="1737360"/>
             <a:ext cx="0" cy="3337560"/>
           </a:xfrm>
           <a:prstGeom prst="line">
@@ -7134,7 +7131,7 @@
         </p:nvCxnSpPr>
         <p:spPr>
           <a:xfrm>
-            <a:off x="10261854" y="1737360"/>
+            <a:off x="9477756" y="1737360"/>
             <a:ext cx="0" cy="3337560"/>
           </a:xfrm>
           <a:prstGeom prst="line">
@@ -7170,7 +7167,7 @@
         </p:nvCxnSpPr>
         <p:spPr>
           <a:xfrm>
-            <a:off x="11045952" y="1737360"/>
+            <a:off x="10261854" y="1737360"/>
             <a:ext cx="0" cy="3337560"/>
           </a:xfrm>
           <a:prstGeom prst="line">
@@ -7198,9 +7195,45 @@
           </a:fontRef>
         </p:style>
       </p:cxnSp>
-      <p:sp>
-        <p:nvSpPr>
-          <p:cNvPr id="22" name="Freeform 21"/>
+      <p:cxnSp>
+        <p:nvCxnSpPr>
+          <p:cNvPr id="22" name="Connector 21"/>
+          <p:cNvCxnSpPr/>
+          <p:nvPr/>
+        </p:nvCxnSpPr>
+        <p:spPr>
+          <a:xfrm>
+            <a:off x="11045952" y="1737360"/>
+            <a:ext cx="0" cy="3337560"/>
+          </a:xfrm>
+          <a:prstGeom prst="line">
+            <a:avLst/>
+          </a:prstGeom>
+          <a:ln w="9525">
+            <a:solidFill>
+              <a:srgbClr val="3E6E58"/>
+            </a:solidFill>
+            <a:prstDash val="dash"/>
+          </a:ln>
+        </p:spPr>
+        <p:style>
+          <a:lnRef idx="2">
+            <a:schemeClr val="accent1"/>
+          </a:lnRef>
+          <a:fillRef idx="0">
+            <a:schemeClr val="accent1"/>
+          </a:fillRef>
+          <a:effectRef idx="1">
+            <a:schemeClr val="accent1"/>
+          </a:effectRef>
+          <a:fontRef idx="minor">
+            <a:schemeClr val="tx1"/>
+          </a:fontRef>
+        </p:style>
+      </p:cxnSp>
+      <p:sp>
+        <p:nvSpPr>
+          <p:cNvPr id="23" name="Freeform 22"/>
           <p:cNvSpPr/>
           <p:nvPr/>
         </p:nvSpPr>
@@ -7267,7 +7300,7 @@
       </p:sp>
       <p:sp>
         <p:nvSpPr>
-          <p:cNvPr id="23" name="Oval 22"/>
+          <p:cNvPr id="24" name="Oval 23"/>
           <p:cNvSpPr/>
           <p:nvPr/>
         </p:nvSpPr>
@@ -7309,7 +7342,7 @@
       </p:sp>
       <p:sp>
         <p:nvSpPr>
-          <p:cNvPr id="24" name="TextBox 23"/>
+          <p:cNvPr id="25" name="TextBox 24"/>
           <p:cNvSpPr txBox="1"/>
           <p:nvPr/>
         </p:nvSpPr>
@@ -7342,7 +7375,7 @@
       </p:sp>
       <p:sp>
         <p:nvSpPr>
-          <p:cNvPr id="25" name="Oval 24"/>
+          <p:cNvPr id="26" name="Oval 25"/>
           <p:cNvSpPr/>
           <p:nvPr/>
         </p:nvSpPr>
@@ -7384,7 +7417,7 @@
       </p:sp>
       <p:sp>
         <p:nvSpPr>
-          <p:cNvPr id="26" name="TextBox 25"/>
+          <p:cNvPr id="27" name="TextBox 26"/>
           <p:cNvSpPr txBox="1"/>
           <p:nvPr/>
         </p:nvSpPr>
@@ -7417,7 +7450,7 @@
       </p:sp>
       <p:sp>
         <p:nvSpPr>
-          <p:cNvPr id="27" name="Oval 26"/>
+          <p:cNvPr id="28" name="Oval 27"/>
           <p:cNvSpPr/>
           <p:nvPr/>
         </p:nvSpPr>
@@ -7459,7 +7492,7 @@
       </p:sp>
       <p:sp>
         <p:nvSpPr>
-          <p:cNvPr id="28" name="TextBox 27"/>
+          <p:cNvPr id="29" name="TextBox 28"/>
           <p:cNvSpPr txBox="1"/>
           <p:nvPr/>
         </p:nvSpPr>
@@ -7492,7 +7525,7 @@
       </p:sp>
       <p:sp>
         <p:nvSpPr>
-          <p:cNvPr id="29" name="Oval 28"/>
+          <p:cNvPr id="30" name="Oval 29"/>
           <p:cNvSpPr/>
           <p:nvPr/>
         </p:nvSpPr>
@@ -7534,7 +7567,7 @@
       </p:sp>
       <p:sp>
         <p:nvSpPr>
-          <p:cNvPr id="30" name="TextBox 29"/>
+          <p:cNvPr id="31" name="TextBox 30"/>
           <p:cNvSpPr txBox="1"/>
           <p:nvPr/>
         </p:nvSpPr>
@@ -7567,7 +7600,7 @@
       </p:sp>
       <p:sp>
         <p:nvSpPr>
-          <p:cNvPr id="31" name="Oval 30"/>
+          <p:cNvPr id="32" name="Oval 31"/>
           <p:cNvSpPr/>
           <p:nvPr/>
         </p:nvSpPr>
@@ -7609,7 +7642,7 @@
       </p:sp>
       <p:sp>
         <p:nvSpPr>
-          <p:cNvPr id="32" name="TextBox 31"/>
+          <p:cNvPr id="33" name="TextBox 32"/>
           <p:cNvSpPr txBox="1"/>
           <p:nvPr/>
         </p:nvSpPr>
@@ -7642,7 +7675,7 @@
       </p:sp>
       <p:sp>
         <p:nvSpPr>
-          <p:cNvPr id="33" name="TextBox 32"/>
+          <p:cNvPr id="34" name="TextBox 33"/>
           <p:cNvSpPr txBox="1"/>
           <p:nvPr/>
         </p:nvSpPr>
@@ -7729,7 +7762,7 @@
                 </a:solidFill>
                 <a:latin typeface="Calibri"/>
               </a:rPr>
-              <a:t>Агрокаст: прогноз и рекомендации в одном сайте</a:t>
+              <a:t>Агрокаст: калькулятор участка — главный экран сайта</a:t>
             </a:r>
           </a:p>
         </p:txBody>
@@ -7837,7 +7870,7 @@
       </p:sp>
       <p:pic>
         <p:nvPicPr>
-          <p:cNvPr id="6" name="Picture 5" descr="Скриншот сайта: карта прогноза урожайности по субъектам РФ со шкалой дат"/>
+          <p:cNvPr id="6" name="Picture 5" descr="Скриншот сайта: калькулятор участка — ввод региона, площади, почвы, сорта и агротехники, результат в т/га, сборе, выручке и марже"/>
           <p:cNvPicPr>
             <a:picLocks noChangeAspect="1"/>
           </p:cNvPicPr>
@@ -7851,12 +7884,12 @@
         </p:blipFill>
         <p:spPr>
           <a:xfrm>
-            <a:off x="548640" y="1737360"/>
-            <a:ext cx="6675120" cy="3931920"/>
+            <a:off x="548640" y="1691640"/>
+            <a:ext cx="4754880" cy="3794760"/>
           </a:xfrm>
           <a:prstGeom prst="roundRect">
             <a:avLst>
-              <a:gd name="adj" fmla="val 2790"/>
+              <a:gd name="adj" fmla="val 2891"/>
             </a:avLst>
           </a:prstGeom>
           <a:ln w="9525">
@@ -7881,8 +7914,8 @@
         </p:nvSpPr>
         <p:spPr>
           <a:xfrm>
-            <a:off x="548640" y="1353312"/>
-            <a:ext cx="2240280" cy="274320"/>
+            <a:off x="548640" y="1307592"/>
+            <a:ext cx="3108960" cy="274320"/>
           </a:xfrm>
           <a:prstGeom prst="roundRect">
             <a:avLst>
@@ -7923,14 +7956,14 @@
                 </a:solidFill>
                 <a:latin typeface="Calibri"/>
               </a:rPr>
-              <a:t>Карта · 7 культур · 5 дат</a:t>
+              <a:t>Калькулятор участка · ввод и результат</a:t>
             </a:r>
           </a:p>
         </p:txBody>
       </p:sp>
       <p:pic>
         <p:nvPicPr>
-          <p:cNvPr id="8" name="Picture 7" descr="Скриншот сайта: карточка региона с историей урожайности, прогнозом и факторами"/>
+          <p:cNvPr id="8" name="Picture 7" descr="Скриншот сайта: карта регионов — региональная модель, основа калькулятора"/>
           <p:cNvPicPr>
             <a:picLocks noChangeAspect="1"/>
           </p:cNvPicPr>
@@ -7944,12 +7977,12 @@
         </p:blipFill>
         <p:spPr>
           <a:xfrm>
-            <a:off x="7525511" y="1737360"/>
-            <a:ext cx="4117543" cy="1760219"/>
+            <a:off x="5605272" y="1691640"/>
+            <a:ext cx="6037783" cy="1691640"/>
           </a:xfrm>
           <a:prstGeom prst="roundRect">
             <a:avLst>
-              <a:gd name="adj" fmla="val 6233"/>
+              <a:gd name="adj" fmla="val 6486"/>
             </a:avLst>
           </a:prstGeom>
           <a:ln w="9525">
@@ -7974,8 +8007,8 @@
         </p:nvSpPr>
         <p:spPr>
           <a:xfrm>
-            <a:off x="7525511" y="1353312"/>
-            <a:ext cx="1600200" cy="274320"/>
+            <a:off x="5605272" y="1307592"/>
+            <a:ext cx="3200400" cy="274320"/>
           </a:xfrm>
           <a:prstGeom prst="roundRect">
             <a:avLst>
@@ -8016,14 +8049,14 @@
                 </a:solidFill>
                 <a:latin typeface="Calibri"/>
               </a:rPr>
-              <a:t>Карточка региона</a:t>
+              <a:t>Карта регионов · основа калькулятора</a:t>
             </a:r>
           </a:p>
         </p:txBody>
       </p:sp>
       <p:pic>
         <p:nvPicPr>
-          <p:cNvPr id="10" name="Picture 9" descr="Скриншот сайта: оптимизация структуры посевов, план «было — стало»"/>
+          <p:cNvPr id="10" name="Picture 9" descr="Скриншот сайта: оптимизация плана посевов, что изменить и эффект"/>
           <p:cNvPicPr>
             <a:picLocks noChangeAspect="1"/>
           </p:cNvPicPr>
@@ -8037,12 +8070,12 @@
         </p:blipFill>
         <p:spPr>
           <a:xfrm>
-            <a:off x="7525511" y="3881628"/>
-            <a:ext cx="4117543" cy="1760219"/>
+            <a:off x="5605272" y="3767328"/>
+            <a:ext cx="6037783" cy="1691640"/>
           </a:xfrm>
           <a:prstGeom prst="roundRect">
             <a:avLst>
-              <a:gd name="adj" fmla="val 6233"/>
+              <a:gd name="adj" fmla="val 6486"/>
             </a:avLst>
           </a:prstGeom>
           <a:ln w="9525">
@@ -8067,8 +8100,8 @@
         </p:nvSpPr>
         <p:spPr>
           <a:xfrm>
-            <a:off x="7525511" y="3561587"/>
-            <a:ext cx="1280160" cy="274320"/>
+            <a:off x="5605272" y="3447288"/>
+            <a:ext cx="2103120" cy="274320"/>
           </a:xfrm>
           <a:prstGeom prst="roundRect">
             <a:avLst>
@@ -8109,7 +8142,7 @@
                 </a:solidFill>
                 <a:latin typeface="Calibri"/>
               </a:rPr>
-              <a:t>Оптимизация</a:t>
+              <a:t>Оптимизация плана</a:t>
             </a:r>
           </a:p>
         </p:txBody>
@@ -8122,12 +8155,12 @@
         </p:nvSpPr>
         <p:spPr>
           <a:xfrm>
-            <a:off x="548640" y="5806440"/>
-            <a:ext cx="11094415" cy="530352"/>
+            <a:off x="548640" y="5623560"/>
+            <a:ext cx="11094415" cy="749808"/>
           </a:xfrm>
           <a:prstGeom prst="roundRect">
             <a:avLst>
-              <a:gd name="adj" fmla="val 24137"/>
+              <a:gd name="adj" fmla="val 17073"/>
             </a:avLst>
           </a:prstGeom>
           <a:solidFill>
@@ -8174,8 +8207,8 @@
         </p:nvSpPr>
         <p:spPr>
           <a:xfrm>
-            <a:off x="822959" y="5806440"/>
-            <a:ext cx="5486400" cy="530352"/>
+            <a:off x="822959" y="5641848"/>
+            <a:ext cx="10545775" cy="713232"/>
           </a:xfrm>
           <a:prstGeom prst="rect">
             <a:avLst/>
@@ -8186,57 +8219,71 @@
           <a:bodyPr wrap="square" lIns="0" rIns="0" tIns="0" bIns="0" anchor="ctr"/>
           <a:lstStyle/>
           <a:p>
-            <a:pPr algn="l"/>
-            <a:r>
-              <a:rPr sz="1500" b="1" i="0" lang="ru-RU">
+            <a:pPr algn="l">
+              <a:spcAft>
+                <a:spcPts val="200"/>
+              </a:spcAft>
+            </a:pPr>
+            <a:r>
+              <a:rPr sz="1300" b="1" i="0" lang="ru-RU">
                 <a:solidFill>
                   <a:srgbClr val="1F4D3A"/>
                 </a:solidFill>
                 <a:latin typeface="Calibri"/>
               </a:rPr>
+              <a:t>Считает модель: </a:t>
+            </a:r>
+            <a:r>
+              <a:rPr sz="1300" b="0" i="0" lang="ru-RU">
+                <a:solidFill>
+                  <a:srgbClr val="5A615B"/>
+                </a:solidFill>
+                <a:latin typeface="Calibri"/>
+              </a:rPr>
+              <a:t>региональный прогноз по погоде и данным региона. </a:t>
+            </a:r>
+            <a:r>
+              <a:rPr sz="1300" b="1" i="0" lang="ru-RU">
+                <a:solidFill>
+                  <a:srgbClr val="C8962E"/>
+                </a:solidFill>
+                <a:latin typeface="Calibri"/>
+              </a:rPr>
+              <a:t>Допущения: </a:t>
+            </a:r>
+            <a:r>
+              <a:rPr sz="1300" b="0" i="0" lang="ru-RU">
+                <a:solidFill>
+                  <a:srgbClr val="5A615B"/>
+                </a:solidFill>
+                <a:latin typeface="Calibri"/>
+              </a:rPr>
+              <a:t>почва, сорт, агротехника, затраты. «Итог сезона» — оценка по фактической погоде, не прогноз.</a:t>
+            </a:r>
+          </a:p>
+          <a:p>
+            <a:pPr algn="l">
+              <a:spcAft>
+                <a:spcPts val="200"/>
+              </a:spcAft>
+            </a:pPr>
+            <a:r>
+              <a:rPr sz="1300" b="1" i="0" lang="ru-RU">
+                <a:solidFill>
+                  <a:srgbClr val="1F4D3A"/>
+                </a:solidFill>
+                <a:latin typeface="Calibri"/>
+              </a:rPr>
               <a:t>Код и сайт: </a:t>
             </a:r>
             <a:r>
-              <a:rPr sz="1500" b="0" i="0" lang="ru-RU">
+              <a:rPr sz="1300" b="0" i="0" lang="ru-RU">
                 <a:solidFill>
                   <a:srgbClr val="1E2420"/>
                 </a:solidFill>
                 <a:latin typeface="Calibri"/>
               </a:rPr>
               <a:t>https://parampaika.github.io/AgroCast/</a:t>
-            </a:r>
-          </a:p>
-        </p:txBody>
-      </p:sp>
-      <p:sp>
-        <p:nvSpPr>
-          <p:cNvPr id="14" name="TextBox 13"/>
-          <p:cNvSpPr txBox="1"/>
-          <p:nvPr/>
-        </p:nvSpPr>
-        <p:spPr>
-          <a:xfrm>
-            <a:off x="6217920" y="5806440"/>
-            <a:ext cx="5150815" cy="530352"/>
-          </a:xfrm>
-          <a:prstGeom prst="rect">
-            <a:avLst/>
-          </a:prstGeom>
-          <a:noFill/>
-        </p:spPr>
-        <p:txBody>
-          <a:bodyPr wrap="square" lIns="0" rIns="0" tIns="0" bIns="0" anchor="ctr"/>
-          <a:lstStyle/>
-          <a:p>
-            <a:pPr algn="r"/>
-            <a:r>
-              <a:rPr sz="1300" b="0" i="0" lang="ru-RU">
-                <a:solidFill>
-                  <a:srgbClr val="5A615B"/>
-                </a:solidFill>
-                <a:latin typeface="Calibri"/>
-              </a:rPr>
-              <a:t>Статический сайт без сервера: работает офлайн, готов к GitHub Pages</a:t>
             </a:r>
           </a:p>
         </p:txBody>
@@ -8510,36 +8557,36 @@
           <a:p>
             <a:pPr algn="l">
               <a:spcAft>
-                <a:spcPts val="1700"/>
+                <a:spcPts val="1200"/>
               </a:spcAft>
             </a:pPr>
             <a:r>
-              <a:rPr sz="1700" b="1" i="0" lang="ru-RU">
+              <a:rPr sz="1600" b="1" i="0" lang="ru-RU">
                 <a:solidFill>
                   <a:srgbClr val="1E2420"/>
                 </a:solidFill>
                 <a:latin typeface="Calibri"/>
               </a:rPr>
-              <a:t>Уровень — субъект РФ.</a:t>
-            </a:r>
-            <a:r>
-              <a:rPr sz="1700" b="0" i="0" lang="ru-RU">
+              <a:t>Модель — региональная, не полевая.</a:t>
+            </a:r>
+            <a:r>
+              <a:rPr sz="1600" b="0" i="0" lang="ru-RU">
                 <a:solidFill>
                   <a:srgbClr val="5A615B"/>
                 </a:solidFill>
                 <a:latin typeface="Calibri"/>
               </a:rPr>
-              <a:t> Хозяйство учитывается поправками на почву, сорт и агротехнику.</a:t>
+              <a:t> Почва, сорт и агротехника — множители-допущения: открытых данных по хозяйствам нет.</a:t>
             </a:r>
           </a:p>
           <a:p>
             <a:pPr algn="l">
               <a:spcAft>
-                <a:spcPts val="1700"/>
+                <a:spcPts val="1200"/>
               </a:spcAft>
             </a:pPr>
             <a:r>
-              <a:rPr sz="1700" b="1" i="0" lang="ru-RU">
+              <a:rPr sz="1600" b="1" i="0" lang="ru-RU">
                 <a:solidFill>
                   <a:srgbClr val="1E2420"/>
                 </a:solidFill>
@@ -8548,7 +8595,7 @@
               <a:t>Короткие ряды:</a:t>
             </a:r>
             <a:r>
-              <a:rPr sz="1700" b="0" i="0" lang="ru-RU">
+              <a:rPr sz="1600" b="0" i="0" lang="ru-RU">
                 <a:solidFill>
                   <a:srgbClr val="5A615B"/>
                 </a:solidFill>
@@ -8560,11 +8607,11 @@
           <a:p>
             <a:pPr algn="l">
               <a:spcAft>
-                <a:spcPts val="1700"/>
+                <a:spcPts val="1200"/>
               </a:spcAft>
             </a:pPr>
             <a:r>
-              <a:rPr sz="1700" b="1" i="0" lang="ru-RU">
+              <a:rPr sz="1600" b="1" i="0" lang="ru-RU">
                 <a:solidFill>
                   <a:srgbClr val="1E2420"/>
                 </a:solidFill>
@@ -8573,7 +8620,7 @@
               <a:t>Интервалы широкие:</a:t>
             </a:r>
             <a:r>
-              <a:rPr sz="1700" b="0" i="0" lang="ru-RU">
+              <a:rPr sz="1600" b="0" i="0" lang="ru-RU">
                 <a:solidFill>
                   <a:srgbClr val="5A615B"/>
                 </a:solidFill>
@@ -8585,11 +8632,11 @@
           <a:p>
             <a:pPr algn="l">
               <a:spcAft>
-                <a:spcPts val="1700"/>
+                <a:spcPts val="1200"/>
               </a:spcAft>
             </a:pPr>
             <a:r>
-              <a:rPr sz="1700" b="1" i="0" lang="ru-RU">
+              <a:rPr sz="1600" b="1" i="0" lang="ru-RU">
                 <a:solidFill>
                   <a:srgbClr val="1E2420"/>
                 </a:solidFill>
@@ -8598,7 +8645,7 @@
               <a:t>2025 год:</a:t>
             </a:r>
             <a:r>
-              <a:rPr sz="1700" b="0" i="0" lang="ru-RU">
+              <a:rPr sz="1600" b="0" i="0" lang="ru-RU">
                 <a:solidFill>
                   <a:srgbClr val="5A615B"/>
                 </a:solidFill>
@@ -8610,11 +8657,11 @@
           <a:p>
             <a:pPr algn="l">
               <a:spcAft>
-                <a:spcPts val="1700"/>
+                <a:spcPts val="1200"/>
               </a:spcAft>
             </a:pPr>
             <a:r>
-              <a:rPr sz="1700" b="1" i="0" lang="ru-RU">
+              <a:rPr sz="1600" b="1" i="0" lang="ru-RU">
                 <a:solidFill>
                   <a:srgbClr val="1E2420"/>
                 </a:solidFill>
@@ -8623,7 +8670,7 @@
               <a:t>Затраты — допущения.</a:t>
             </a:r>
             <a:r>
-              <a:rPr sz="1700" b="0" i="0" lang="ru-RU">
+              <a:rPr sz="1600" b="0" i="0" lang="ru-RU">
                 <a:solidFill>
                   <a:srgbClr val="5A615B"/>
                 </a:solidFill>
@@ -8783,7 +8830,7 @@
                 </a:solidFill>
                 <a:latin typeface="Calibri"/>
               </a:rPr>
-              <a:t>Районы и хозяйства</a:t>
+              <a:t>Калибровка множителей</a:t>
             </a:r>
           </a:p>
         </p:txBody>
@@ -8816,7 +8863,7 @@
                 </a:solidFill>
                 <a:latin typeface="Calibri"/>
               </a:rPr>
-              <a:t>данные уровня района и хозяйства вместо региона</a:t>
+              <a:t>опытные станции, данные хозяйств и банка вместо допущений; уровень района</a:t>
             </a:r>
           </a:p>
         </p:txBody>
@@ -10176,7 +10223,7 @@
                 </a:solidFill>
                 <a:latin typeface="Calibri"/>
               </a:rPr>
-              <a:t>Прогноз — это решение: что сеять и сколько вложить</a:t>
+              <a:t>Калькулятор участка: что сеять и сколько вложить</a:t>
             </a:r>
           </a:p>
         </p:txBody>
@@ -10242,7 +10289,7 @@
                 </a:solidFill>
                 <a:latin typeface="Calibri"/>
               </a:rPr>
-              <a:t>Кейс: урожайность в т/га и общий объём по культурам и польза для планирования затрат и доходов</a:t>
+              <a:t>Кейс: оценить урожайность по участку, показать т/га и общий объём по культурам, объяснить пользу для затрат и доходов</a:t>
             </a:r>
           </a:p>
         </p:txBody>
@@ -10897,7 +10944,7 @@
                 </a:solidFill>
                 <a:latin typeface="Calibri"/>
               </a:rPr>
-              <a:t>Прогноз на 5 дат сезона с честным интервалом</a:t>
+              <a:t>Калькулятор: регион, площадь, почва, сорт, агротехника → т/га, сбор, выручка, маржа</a:t>
             </a:r>
           </a:p>
           <a:p>
@@ -10913,7 +10960,7 @@
                 </a:solidFill>
                 <a:latin typeface="Calibri"/>
               </a:rPr>
-              <a:t>Оптимизация: что изменить в плане, чтобы заработать больше при том же риске</a:t>
+              <a:t>Основа — региональный прогноз на 5 дат сезона с честным интервалом</a:t>
             </a:r>
           </a:p>
           <a:p>
@@ -10929,7 +10976,7 @@
                 </a:solidFill>
                 <a:latin typeface="Calibri"/>
               </a:rPr>
-              <a:t>Сайт с калькулятором хозяйства</a:t>
+              <a:t>Оптимизация: что изменить в плане при том же риске</a:t>
             </a:r>
           </a:p>
         </p:txBody>
@@ -14237,7 +14284,7 @@
                 </a:solidFill>
                 <a:latin typeface="Calibri"/>
               </a:rPr>
-              <a:t>карта · регион · калькулятор · оптимизация</a:t>
+              <a:t>калькулятор · регионы · карточка · оптимизация</a:t>
             </a:r>
           </a:p>
         </p:txBody>
@@ -20373,8 +20420,8 @@
         </p:nvSpPr>
         <p:spPr>
           <a:xfrm>
-            <a:off x="548640" y="5989320"/>
-            <a:ext cx="11094415" cy="365760"/>
+            <a:off x="548640" y="5916168"/>
+            <a:ext cx="11094415" cy="457200"/>
           </a:xfrm>
           <a:prstGeom prst="rect">
             <a:avLst/>
@@ -20385,7 +20432,11 @@
           <a:bodyPr wrap="square" lIns="0" rIns="0" tIns="0" bIns="0" anchor="t"/>
           <a:lstStyle/>
           <a:p>
-            <a:pPr algn="l"/>
+            <a:pPr algn="l">
+              <a:spcAft>
+                <a:spcPts val="100"/>
+              </a:spcAft>
+            </a:pPr>
             <a:r>
               <a:rPr sz="1200" b="0" i="0" lang="ru-RU">
                 <a:solidFill>
@@ -20394,6 +20445,31 @@
                 <a:latin typeface="Calibri"/>
               </a:rPr>
               <a:t>Тренды и нормы — только по годам &lt; t · гиперпараметры подобраны по 2012–2018, годы 2019–2025 отложены · случайного разбиения нет</a:t>
+            </a:r>
+          </a:p>
+          <a:p>
+            <a:pPr algn="l">
+              <a:spcAft>
+                <a:spcPts val="100"/>
+              </a:spcAft>
+            </a:pPr>
+            <a:r>
+              <a:rPr sz="1200" b="1" i="0" lang="ru-RU">
+                <a:solidFill>
+                  <a:srgbClr val="5A615B"/>
+                </a:solidFill>
+                <a:latin typeface="Calibri"/>
+              </a:rPr>
+              <a:t>Модель обучена на данных региона; </a:t>
+            </a:r>
+            <a:r>
+              <a:rPr sz="1200" b="0" i="0" lang="ru-RU">
+                <a:solidFill>
+                  <a:srgbClr val="5A615B"/>
+                </a:solidFill>
+                <a:latin typeface="Calibri"/>
+              </a:rPr>
+              <a:t>почва, сорт, агротехника — множители-допущения. «Конец сезона» — оценка по фактической погоде</a:t>
             </a:r>
           </a:p>
         </p:txBody>

</xml_diff>